<commit_message>
Reporte en pptx final
</commit_message>
<xml_diff>
--- a/Reporte 131026.pptx
+++ b/Reporte 131026.pptx
@@ -6574,10 +6574,10 @@
       </p:sp>
       <p:pic>
         <p:nvPicPr>
-          <p:cNvPr id="4" name="Imagen 3">
+          <p:cNvPr id="5" name="Imagen 4">
             <a:extLst>
               <a:ext uri="{FF2B5EF4-FFF2-40B4-BE49-F238E27FC236}">
-                <a16:creationId xmlns:a16="http://schemas.microsoft.com/office/drawing/2014/main" id="{F5F75A67-5586-12EA-73F5-093CB18C2106}"/>
+                <a16:creationId xmlns:a16="http://schemas.microsoft.com/office/drawing/2014/main" id="{21E707AF-25CA-04A1-3FE8-1ADEE834564C}"/>
               </a:ext>
             </a:extLst>
           </p:cNvPr>
@@ -6594,8 +6594,8 @@
         </p:blipFill>
         <p:spPr>
           <a:xfrm>
-            <a:off x="0" y="943277"/>
-            <a:ext cx="9144000" cy="3399822"/>
+            <a:off x="0" y="503430"/>
+            <a:ext cx="9144000" cy="4279515"/>
           </a:xfrm>
           <a:prstGeom prst="rect">
             <a:avLst/>
@@ -6680,10 +6680,10 @@
       </p:sp>
       <p:pic>
         <p:nvPicPr>
-          <p:cNvPr id="4" name="Imagen 3">
+          <p:cNvPr id="3" name="Imagen 2">
             <a:extLst>
               <a:ext uri="{FF2B5EF4-FFF2-40B4-BE49-F238E27FC236}">
-                <a16:creationId xmlns:a16="http://schemas.microsoft.com/office/drawing/2014/main" id="{79266257-D1FB-7130-BC5C-4D5D40E44AC1}"/>
+                <a16:creationId xmlns:a16="http://schemas.microsoft.com/office/drawing/2014/main" id="{785B82A7-1CAC-4AF0-93F9-5505410009F2}"/>
               </a:ext>
             </a:extLst>
           </p:cNvPr>
@@ -6700,8 +6700,8 @@
         </p:blipFill>
         <p:spPr>
           <a:xfrm>
-            <a:off x="0" y="1312003"/>
-            <a:ext cx="9144000" cy="2662369"/>
+            <a:off x="0" y="977401"/>
+            <a:ext cx="9144000" cy="3331574"/>
           </a:xfrm>
           <a:prstGeom prst="rect">
             <a:avLst/>
@@ -6786,10 +6786,10 @@
       </p:sp>
       <p:pic>
         <p:nvPicPr>
-          <p:cNvPr id="5" name="Imagen 4">
+          <p:cNvPr id="4" name="Imagen 3">
             <a:extLst>
               <a:ext uri="{FF2B5EF4-FFF2-40B4-BE49-F238E27FC236}">
-                <a16:creationId xmlns:a16="http://schemas.microsoft.com/office/drawing/2014/main" id="{85844061-38D0-580F-EF84-BBD84C768051}"/>
+                <a16:creationId xmlns:a16="http://schemas.microsoft.com/office/drawing/2014/main" id="{5CC3F6AE-09E7-8942-E10C-86402CA6DC34}"/>
               </a:ext>
             </a:extLst>
           </p:cNvPr>
@@ -6806,8 +6806,8 @@
         </p:blipFill>
         <p:spPr>
           <a:xfrm>
-            <a:off x="0" y="696594"/>
-            <a:ext cx="9144000" cy="3893188"/>
+            <a:off x="0" y="797097"/>
+            <a:ext cx="9144000" cy="3692182"/>
           </a:xfrm>
           <a:prstGeom prst="rect">
             <a:avLst/>
@@ -6892,10 +6892,10 @@
       </p:sp>
       <p:pic>
         <p:nvPicPr>
-          <p:cNvPr id="4" name="Imagen 3">
+          <p:cNvPr id="2" name="Imagen 1">
             <a:extLst>
               <a:ext uri="{FF2B5EF4-FFF2-40B4-BE49-F238E27FC236}">
-                <a16:creationId xmlns:a16="http://schemas.microsoft.com/office/drawing/2014/main" id="{AABF67A7-F00E-18A7-75DB-C590A731776D}"/>
+                <a16:creationId xmlns:a16="http://schemas.microsoft.com/office/drawing/2014/main" id="{82A0840B-3C0C-62E4-8C40-9A69DCA856FB}"/>
               </a:ext>
             </a:extLst>
           </p:cNvPr>
@@ -6912,8 +6912,8 @@
         </p:blipFill>
         <p:spPr>
           <a:xfrm>
-            <a:off x="0" y="1331839"/>
-            <a:ext cx="9144000" cy="2622698"/>
+            <a:off x="0" y="1451183"/>
+            <a:ext cx="9144000" cy="2384009"/>
           </a:xfrm>
           <a:prstGeom prst="rect">
             <a:avLst/>
@@ -6998,10 +6998,10 @@
       </p:sp>
       <p:pic>
         <p:nvPicPr>
-          <p:cNvPr id="7" name="Imagen 6">
+          <p:cNvPr id="3" name="Imagen 2">
             <a:extLst>
               <a:ext uri="{FF2B5EF4-FFF2-40B4-BE49-F238E27FC236}">
-                <a16:creationId xmlns:a16="http://schemas.microsoft.com/office/drawing/2014/main" id="{1D555DCF-A241-A5A3-4DC4-256B3EB43B08}"/>
+                <a16:creationId xmlns:a16="http://schemas.microsoft.com/office/drawing/2014/main" id="{BB9E8213-DA96-35CF-9B9F-9962D2334033}"/>
               </a:ext>
             </a:extLst>
           </p:cNvPr>
@@ -7018,8 +7018,8 @@
         </p:blipFill>
         <p:spPr>
           <a:xfrm>
-            <a:off x="0" y="703321"/>
-            <a:ext cx="9144000" cy="3879734"/>
+            <a:off x="0" y="670167"/>
+            <a:ext cx="9144000" cy="3946042"/>
           </a:xfrm>
           <a:prstGeom prst="rect">
             <a:avLst/>
@@ -7110,10 +7110,10 @@
       </p:sp>
       <p:pic>
         <p:nvPicPr>
-          <p:cNvPr id="4" name="Imagen 3">
+          <p:cNvPr id="3" name="Imagen 2">
             <a:extLst>
               <a:ext uri="{FF2B5EF4-FFF2-40B4-BE49-F238E27FC236}">
-                <a16:creationId xmlns:a16="http://schemas.microsoft.com/office/drawing/2014/main" id="{612BB0A5-593E-BA5D-68C7-880BF1B9AD7F}"/>
+                <a16:creationId xmlns:a16="http://schemas.microsoft.com/office/drawing/2014/main" id="{B2CB4F50-E30A-38B2-05BB-7101BEE28939}"/>
               </a:ext>
             </a:extLst>
           </p:cNvPr>
@@ -7130,8 +7130,8 @@
         </p:blipFill>
         <p:spPr>
           <a:xfrm>
-            <a:off x="0" y="1030993"/>
-            <a:ext cx="9144000" cy="3224389"/>
+            <a:off x="682625" y="547688"/>
+            <a:ext cx="7705725" cy="4191000"/>
           </a:xfrm>
           <a:prstGeom prst="rect">
             <a:avLst/>

</xml_diff>